<commit_message>
Correct ontology synthesis and align comparative study material
</commit_message>
<xml_diff>
--- a/Studies/Axiology-Value-Theory/Axiology-Value-Theory-Madhyasth-Darshan.pptx
+++ b/Studies/Axiology-Value-Theory/Axiology-Value-Theory-Madhyasth-Darshan.pptx
@@ -2,37 +2,37 @@
 <file path=ppt/presentation.xml><?xml version="1.0" encoding="utf-8"?>
 <p:presentation xmlns:p="http://schemas.openxmlformats.org/presentationml/2006/main">
   <p:sldMasterIdLst>
-    <p:sldMasterId xmlns:r="http://schemas.openxmlformats.org/officeDocument/2006/relationships" id="2147483648" r:id="R64302cfabafe41fa"/>
+    <p:sldMasterId xmlns:r="http://schemas.openxmlformats.org/officeDocument/2006/relationships" id="2147483648" r:id="R39afcdd053054c19"/>
   </p:sldMasterIdLst>
   <p:notesMasterIdLst>
-    <p:notesMasterId xmlns:r="http://schemas.openxmlformats.org/officeDocument/2006/relationships" r:id="R80c2d6c608cb41aa"/>
+    <p:notesMasterId xmlns:r="http://schemas.openxmlformats.org/officeDocument/2006/relationships" r:id="R1a021c973824451e"/>
   </p:notesMasterIdLst>
   <p:sldIdLst>
-    <p:sldId xmlns:r="http://schemas.openxmlformats.org/officeDocument/2006/relationships" id="256" r:id="Rc2f712019aec4cb9"/>
-    <p:sldId xmlns:r="http://schemas.openxmlformats.org/officeDocument/2006/relationships" id="257" r:id="Rc6f8ddef50a04d1e"/>
-    <p:sldId xmlns:r="http://schemas.openxmlformats.org/officeDocument/2006/relationships" id="258" r:id="R6d9ecc7015084932"/>
-    <p:sldId xmlns:r="http://schemas.openxmlformats.org/officeDocument/2006/relationships" id="259" r:id="R411eb7ab53484619"/>
-    <p:sldId xmlns:r="http://schemas.openxmlformats.org/officeDocument/2006/relationships" id="260" r:id="R0dca5d60799c45cb"/>
-    <p:sldId xmlns:r="http://schemas.openxmlformats.org/officeDocument/2006/relationships" id="261" r:id="Rc2fe8d7c08fb4544"/>
-    <p:sldId xmlns:r="http://schemas.openxmlformats.org/officeDocument/2006/relationships" id="262" r:id="R5a80c1d089074113"/>
-    <p:sldId xmlns:r="http://schemas.openxmlformats.org/officeDocument/2006/relationships" id="263" r:id="R57bab2a4f9a5492d"/>
-    <p:sldId xmlns:r="http://schemas.openxmlformats.org/officeDocument/2006/relationships" id="264" r:id="Rd18ae07151ef4b9a"/>
-    <p:sldId xmlns:r="http://schemas.openxmlformats.org/officeDocument/2006/relationships" id="265" r:id="Rc3430765082c4462"/>
-    <p:sldId xmlns:r="http://schemas.openxmlformats.org/officeDocument/2006/relationships" id="266" r:id="Re9a045f4d0d44b2b"/>
-    <p:sldId xmlns:r="http://schemas.openxmlformats.org/officeDocument/2006/relationships" id="267" r:id="Rd5fdbf3afc0e4837"/>
-    <p:sldId xmlns:r="http://schemas.openxmlformats.org/officeDocument/2006/relationships" id="268" r:id="Ra79bac2993b54a8f"/>
-    <p:sldId xmlns:r="http://schemas.openxmlformats.org/officeDocument/2006/relationships" id="269" r:id="Rb9a0da98f1d34cfd"/>
-    <p:sldId xmlns:r="http://schemas.openxmlformats.org/officeDocument/2006/relationships" id="270" r:id="R0b11d114050c432c"/>
-    <p:sldId xmlns:r="http://schemas.openxmlformats.org/officeDocument/2006/relationships" id="271" r:id="Rdfae482773fd4509"/>
-    <p:sldId xmlns:r="http://schemas.openxmlformats.org/officeDocument/2006/relationships" id="272" r:id="R15e928251a2249e3"/>
-    <p:sldId xmlns:r="http://schemas.openxmlformats.org/officeDocument/2006/relationships" id="273" r:id="R084307d0ee444d19"/>
-    <p:sldId xmlns:r="http://schemas.openxmlformats.org/officeDocument/2006/relationships" id="274" r:id="R02b91cd20d7a46f3"/>
-    <p:sldId xmlns:r="http://schemas.openxmlformats.org/officeDocument/2006/relationships" id="275" r:id="Rddbca49f533f4c68"/>
-    <p:sldId xmlns:r="http://schemas.openxmlformats.org/officeDocument/2006/relationships" id="276" r:id="R975ab17f9a1343ff"/>
-    <p:sldId xmlns:r="http://schemas.openxmlformats.org/officeDocument/2006/relationships" id="277" r:id="Rbd67e9f64d194210"/>
-    <p:sldId xmlns:r="http://schemas.openxmlformats.org/officeDocument/2006/relationships" id="278" r:id="Rc8aa1f2bc9844991"/>
-    <p:sldId xmlns:r="http://schemas.openxmlformats.org/officeDocument/2006/relationships" id="279" r:id="R64bb47f434a84c48"/>
-    <p:sldId xmlns:r="http://schemas.openxmlformats.org/officeDocument/2006/relationships" id="280" r:id="R20f999efe7574939"/>
+    <p:sldId xmlns:r="http://schemas.openxmlformats.org/officeDocument/2006/relationships" id="256" r:id="R9bc6bd0ddfdd4272"/>
+    <p:sldId xmlns:r="http://schemas.openxmlformats.org/officeDocument/2006/relationships" id="257" r:id="R7b395d64eede431a"/>
+    <p:sldId xmlns:r="http://schemas.openxmlformats.org/officeDocument/2006/relationships" id="258" r:id="Re5bdb7189d5a4e7a"/>
+    <p:sldId xmlns:r="http://schemas.openxmlformats.org/officeDocument/2006/relationships" id="259" r:id="Rc25a4f30a9094050"/>
+    <p:sldId xmlns:r="http://schemas.openxmlformats.org/officeDocument/2006/relationships" id="260" r:id="R91a66ff2596247ed"/>
+    <p:sldId xmlns:r="http://schemas.openxmlformats.org/officeDocument/2006/relationships" id="261" r:id="Re9c48810dd274689"/>
+    <p:sldId xmlns:r="http://schemas.openxmlformats.org/officeDocument/2006/relationships" id="262" r:id="R290df74c368c4e05"/>
+    <p:sldId xmlns:r="http://schemas.openxmlformats.org/officeDocument/2006/relationships" id="263" r:id="R6b8fe5a744094897"/>
+    <p:sldId xmlns:r="http://schemas.openxmlformats.org/officeDocument/2006/relationships" id="264" r:id="Rf726bc82279a481b"/>
+    <p:sldId xmlns:r="http://schemas.openxmlformats.org/officeDocument/2006/relationships" id="265" r:id="R77fa9a3fe3ca48d9"/>
+    <p:sldId xmlns:r="http://schemas.openxmlformats.org/officeDocument/2006/relationships" id="266" r:id="Rad818b1758ba4265"/>
+    <p:sldId xmlns:r="http://schemas.openxmlformats.org/officeDocument/2006/relationships" id="267" r:id="R1853857bd7974dfe"/>
+    <p:sldId xmlns:r="http://schemas.openxmlformats.org/officeDocument/2006/relationships" id="268" r:id="Ra1c2ae65a4d74d2b"/>
+    <p:sldId xmlns:r="http://schemas.openxmlformats.org/officeDocument/2006/relationships" id="269" r:id="Reb0a3d35f11c4b41"/>
+    <p:sldId xmlns:r="http://schemas.openxmlformats.org/officeDocument/2006/relationships" id="270" r:id="R02d77dd0b2cb4fb7"/>
+    <p:sldId xmlns:r="http://schemas.openxmlformats.org/officeDocument/2006/relationships" id="271" r:id="R7c4b54e0d78c4c53"/>
+    <p:sldId xmlns:r="http://schemas.openxmlformats.org/officeDocument/2006/relationships" id="272" r:id="R5ff6503c17e5467d"/>
+    <p:sldId xmlns:r="http://schemas.openxmlformats.org/officeDocument/2006/relationships" id="273" r:id="R64620f5f20ef4076"/>
+    <p:sldId xmlns:r="http://schemas.openxmlformats.org/officeDocument/2006/relationships" id="274" r:id="R3a8b99e6e47b4308"/>
+    <p:sldId xmlns:r="http://schemas.openxmlformats.org/officeDocument/2006/relationships" id="275" r:id="R738e631d5699441c"/>
+    <p:sldId xmlns:r="http://schemas.openxmlformats.org/officeDocument/2006/relationships" id="276" r:id="R19b315cfde064d62"/>
+    <p:sldId xmlns:r="http://schemas.openxmlformats.org/officeDocument/2006/relationships" id="277" r:id="R773d55dbade94941"/>
+    <p:sldId xmlns:r="http://schemas.openxmlformats.org/officeDocument/2006/relationships" id="278" r:id="R01fc86f59bf240c4"/>
+    <p:sldId xmlns:r="http://schemas.openxmlformats.org/officeDocument/2006/relationships" id="279" r:id="Rf961b4b019fd4077"/>
+    <p:sldId xmlns:r="http://schemas.openxmlformats.org/officeDocument/2006/relationships" id="280" r:id="Refccc7afb5bb418c"/>
   </p:sldIdLst>
   <p:sldSz cx="9144000" cy="5143500"/>
   <p:notesSz cx="6858000" cy="9144000"/>
@@ -2446,7 +2446,7 @@
           <a:lstStyle xmlns:a="http://schemas.openxmlformats.org/drawingml/2006/main"/>
           <a:p xmlns:a="http://schemas.openxmlformats.org/drawingml/2006/main">
             <a:r>
-              <a:t>Each faculty has an activity in state as strength and an activity in motion as power. The checked Hindi account pairs tasting with selection, deliberation with analysis, contemplation with visualisation, understanding with resolve, and realisation with evidence. These are coordinated conscious activities, not a sequence of isolated compartments. Praman names evidence at Atma; it must not be relocated to Buddhi.</a:t>
+              <a:t>Each faculty has an activity in state as strength and an activity in motion as power. The checked Hindi account pairs tasting with selection, deliberation with analysis, contemplation with visualisation, comprehension with resolve, and realisation with evidence. These are coordinated conscious activities, not a sequence of isolated compartments. Here praman follows KD’s evidence-power wording at atma. MVD and SB name its outward activity pramanikta, authenticity. Faculty, characteristic power and paired activity are related distinctions; evidence must not be relocated to buddhi.</a:t>
             </a:r>
           </a:p>
           <a:p xmlns:a="http://schemas.openxmlformats.org/drawingml/2006/main">
@@ -2714,7 +2714,7 @@
   </p:cSld>
   <p:clrMap bg1="lt1" tx1="dk1" bg2="lt2" tx2="dk2" accent1="accent1" accent2="accent2" accent3="accent3" accent4="accent4" accent5="accent5" accent6="accent6" hlink="hlink" folHlink="folHlink"/>
   <p:sldLayoutIdLst>
-    <p:sldLayoutId xmlns:r="http://schemas.openxmlformats.org/officeDocument/2006/relationships" id="2147483649" r:id="R49e921f8f75c4600"/>
+    <p:sldLayoutId xmlns:r="http://schemas.openxmlformats.org/officeDocument/2006/relationships" id="2147483649" r:id="R0d997120c65b4d01"/>
   </p:sldLayoutIdLst>
   <p:txStyles>
     <p:titleStyle>
@@ -3269,7 +3269,7 @@
           <p:nvPr/>
         </p:nvPicPr>
         <p:blipFill>
-          <a:blip xmlns:r="http://schemas.openxmlformats.org/officeDocument/2006/relationships" xmlns:a="http://schemas.openxmlformats.org/drawingml/2006/main" r:embed="R8eb931e3f32348e4"/>
+          <a:blip xmlns:r="http://schemas.openxmlformats.org/officeDocument/2006/relationships" xmlns:a="http://schemas.openxmlformats.org/drawingml/2006/main" r:embed="Rfcee3a20c7a34b1e"/>
           <a:srcRect xmlns:a="http://schemas.openxmlformats.org/drawingml/2006/main" l="0" t="27" r="0" b="27"/>
           <a:stretch xmlns:a="http://schemas.openxmlformats.org/drawingml/2006/main">
             <a:fillRect l="0" t="0" r="0" b="0"/>
@@ -20467,7 +20467,7 @@
                           <a:ea typeface="Calibri"/>
                           <a:cs typeface="Calibri"/>
                         </a:rPr>
-                        <a:t>Buddhi: understanding · bodh</a:t>
+                        <a:t>Buddhi: comprehension · bodh</a:t>
                       </a:r>
                     </a:p>
                   </a:txBody>

</xml_diff>